<commit_message>
refactor(pptx): share the paragraph cascade in pptx-parse; list indents clamp and follow position
- pptx-parse cascade.rs holds the placeholder lookup, the master text-style
  pick, the position-else-level paragraph lookup and the ordered property
  sources; pptx-render and pptx-edit fold them with their own merge, and
  save.rs uses master_for_layout instead of its copy. Render output is
  unchanged (175 fixture slides' display lists identical).
- A newly listed paragraph gets the item's laid-out marL/indent written
  unless it already inherits the same value, so a layout paragraph looked
  up by position no longer misaligns it; copied values are clamped to the
  schema range so an out-of-range file value cannot break the room.
- Each item is resolved once; the fixture keeps the inherited indent in the
  master's bodyStyle and adds a positioned placeholder and a table cell.

Co-Authored-By: Claude Opus 5.5 <noreply@anthropic.com>
</commit_message>
<xml_diff>
--- a/crates/pptx-render/tests/fixtures/list-style-plain-paragraph.pptx
+++ b/crates/pptx-render/tests/fixtures/list-style-plain-paragraph.pptx
@@ -81,7 +81,7 @@
         <p:txBody>
           <a:bodyPr lIns="0" rIns="0" tIns="0" bIns="0"/>
           <a:lstStyle>
-            <a:lvl1pPr marL="228600" indent="-228600">
+            <a:lvl1pPr>
               <a:buClr>
                 <a:srgbClr val="D02020"/>
               </a:buClr>
@@ -110,6 +110,43 @@
             <a:r>
               <a:rPr/>
               <a:t>Body prompt</a:t>
+            </a:r>
+          </a:p>
+        </p:txBody>
+      </p:sp>
+      <p:sp>
+        <p:nvSpPr>
+          <p:cNvPr id="4" name="Positioned prompt"/>
+          <p:cNvSpPr/>
+          <p:nvPr>
+            <p:ph type="body" idx="2"/>
+          </p:nvPr>
+        </p:nvSpPr>
+        <p:spPr>
+          <a:xfrm>
+            <a:off x="609600" y="5486400"/>
+            <a:ext cx="5715000" cy="914400"/>
+          </a:xfrm>
+          <a:prstGeom prst="rect">
+            <a:avLst/>
+          </a:prstGeom>
+          <a:noFill/>
+        </p:spPr>
+        <p:txBody>
+          <a:bodyPr lIns="0" rIns="0" tIns="0" bIns="0"/>
+          <a:lstStyle/>
+          <a:p>
+            <a:pPr marL="114300" indent="-114300"/>
+            <a:r>
+              <a:rPr/>
+              <a:t>First prompt</a:t>
+            </a:r>
+          </a:p>
+          <a:p>
+            <a:pPr marL="457200" indent="-228600"/>
+            <a:r>
+              <a:rPr/>
+              <a:t>Second prompt</a:t>
             </a:r>
           </a:p>
         </p:txBody>
@@ -186,7 +223,7 @@
       </a:lvl1pPr>
     </p:titleStyle>
     <p:bodyStyle>
-      <a:lvl1pPr>
+      <a:lvl1pPr marL="228600" indent="-228600">
         <a:defRPr sz="1800">
           <a:solidFill>
             <a:srgbClr val="505050"/>
@@ -409,6 +446,87 @@
           </a:p>
         </p:txBody>
       </p:sp>
+      <p:sp>
+        <p:nvSpPr>
+          <p:cNvPr id="6" name="Positioned bullets"/>
+          <p:cNvSpPr/>
+          <p:nvPr>
+            <p:ph type="body" idx="2"/>
+          </p:nvPr>
+        </p:nvSpPr>
+        <p:spPr/>
+        <p:txBody>
+          <a:bodyPr lIns="0" rIns="0" tIns="0" bIns="0"/>
+          <a:lstStyle/>
+          <a:p>
+            <a:r>
+              <a:rPr/>
+              <a:t>Plain line</a:t>
+            </a:r>
+          </a:p>
+          <a:p>
+            <a:pPr>
+              <a:buChar char="•"/>
+            </a:pPr>
+            <a:r>
+              <a:rPr/>
+              <a:t>Bulleted line</a:t>
+            </a:r>
+          </a:p>
+        </p:txBody>
+      </p:sp>
+      <p:graphicFrame>
+        <p:nvGraphicFramePr>
+          <p:cNvPr id="7" name="List table"/>
+          <p:cNvGraphicFramePr>
+            <a:graphicFrameLocks noGrp="1"/>
+          </p:cNvGraphicFramePr>
+          <p:nvPr/>
+        </p:nvGraphicFramePr>
+        <p:xfrm>
+          <a:off x="7048500" y="5486400"/>
+          <a:ext cx="4286250" cy="914400"/>
+        </p:xfrm>
+        <a:graphic>
+          <a:graphicData uri="http://schemas.openxmlformats.org/drawingml/2006/table">
+            <a:tbl>
+              <a:tblPr/>
+              <a:tblGrid>
+                <a:gridCol w="4286250"/>
+              </a:tblGrid>
+              <a:tr h="914400">
+                <a:tc>
+                  <a:txBody>
+                    <a:bodyPr/>
+                    <a:lstStyle>
+                      <a:lvl1pPr marL="171450" indent="-171450"/>
+                    </a:lstStyle>
+                    <a:p>
+                      <a:pPr marL="0" indent="0">
+                        <a:buNone/>
+                      </a:pPr>
+                      <a:r>
+                        <a:rPr lang="en-US"/>
+                        <a:t>Plain cell line</a:t>
+                      </a:r>
+                    </a:p>
+                    <a:p>
+                      <a:pPr>
+                        <a:buChar char="•"/>
+                      </a:pPr>
+                      <a:r>
+                        <a:rPr lang="en-US"/>
+                        <a:t>Bulleted cell line</a:t>
+                      </a:r>
+                    </a:p>
+                  </a:txBody>
+                  <a:tcPr/>
+                </a:tc>
+              </a:tr>
+            </a:tbl>
+          </a:graphicData>
+        </a:graphic>
+      </p:graphicFrame>
     </p:spTree>
   </p:cSld>
 </p:sld>

</xml_diff>